<commit_message>
refactor: Update author attribution strictly to 'Howard Liao Ph.D.'
</commit_message>
<xml_diff>
--- a/AI財務分析及金融防詐_HowardLiao.pptx
+++ b/AI財務分析及金融防詐_HowardLiao.pptx
@@ -3331,7 +3331,7 @@
               </a:defRPr>
             </a:pPr>
             <a:r>
-              <a:t>報告人：Howard Liao Ph.D. (廖倫豪 博士)</a:t>
+              <a:t>報告人：Howard Liao Ph.D.</a:t>
             </a:r>
           </a:p>
           <a:p>
@@ -3570,7 +3570,7 @@
               </a:defRPr>
             </a:pPr>
             <a:r>
-              <a:t>AI 時代的智慧財務分析、認知防禦與全維度金融防詐工程論  |  報告人：Howard Liao Ph.D. (廖倫豪 博士)</a:t>
+              <a:t>AI 時代的智慧財務分析、認知防禦與全維度金融防詐工程論  |  報告人：Howard Liao Ph.D.</a:t>
             </a:r>
           </a:p>
         </p:txBody>
@@ -4510,7 +4510,7 @@
               </a:defRPr>
             </a:pPr>
             <a:r>
-              <a:t>AI 時代的智慧財務分析、認知防禦與全維度金融防詐工程論  |  報告人：Howard Liao Ph.D. (廖倫豪 博士)</a:t>
+              <a:t>AI 時代的智慧財務分析、認知防禦與全維度金融防詐工程論  |  報告人：Howard Liao Ph.D.</a:t>
             </a:r>
           </a:p>
         </p:txBody>
@@ -5269,7 +5269,7 @@
               </a:defRPr>
             </a:pPr>
             <a:r>
-              <a:t>AI 時代的智慧財務分析、認知防禦與全維度金融防詐工程論  |  報告人：Howard Liao Ph.D. (廖倫豪 博士)</a:t>
+              <a:t>AI 時代的智慧財務分析、認知防禦與全維度金融防詐工程論  |  報告人：Howard Liao Ph.D.</a:t>
             </a:r>
           </a:p>
         </p:txBody>
@@ -5854,7 +5854,7 @@
               </a:defRPr>
             </a:pPr>
             <a:r>
-              <a:t>AI 時代的智慧財務分析、認知防禦與全維度金融防詐工程論  |  報告人：Howard Liao Ph.D. (廖倫豪 博士)</a:t>
+              <a:t>AI 時代的智慧財務分析、認知防禦與全維度金融防詐工程論  |  報告人：Howard Liao Ph.D.</a:t>
             </a:r>
           </a:p>
         </p:txBody>
@@ -6230,7 +6230,7 @@
               </a:defRPr>
             </a:pPr>
             <a:r>
-              <a:t>AI 時代的智慧財務分析、認知防禦與全維度金融防詐工程論  |  報告人：Howard Liao Ph.D. (廖倫豪 博士)</a:t>
+              <a:t>AI 時代的智慧財務分析、認知防禦與全維度金融防詐工程論  |  報告人：Howard Liao Ph.D.</a:t>
             </a:r>
           </a:p>
         </p:txBody>
@@ -7004,7 +7004,7 @@
               </a:defRPr>
             </a:pPr>
             <a:r>
-              <a:t>AI 時代的智慧財務分析、認知防禦與全維度金融防詐工程論  |  報告人：Howard Liao Ph.D. (廖倫豪 博士)</a:t>
+              <a:t>AI 時代的智慧財務分析、認知防禦與全維度金融防詐工程論  |  報告人：Howard Liao Ph.D.</a:t>
             </a:r>
           </a:p>
         </p:txBody>
@@ -7688,7 +7688,7 @@
               </a:defRPr>
             </a:pPr>
             <a:r>
-              <a:t>AI 時代的智慧財務分析、認知防禦與全維度金融防詐工程論  |  報告人：Howard Liao Ph.D. (廖倫豪 博士)</a:t>
+              <a:t>AI 時代的智慧財務分析、認知防禦與全維度金融防詐工程論  |  報告人：Howard Liao Ph.D.</a:t>
             </a:r>
           </a:p>
         </p:txBody>
@@ -8457,7 +8457,7 @@
               </a:defRPr>
             </a:pPr>
             <a:r>
-              <a:t>AI 時代的智慧財務分析、認知防禦與全維度金融防詐工程論  |  報告人：Howard Liao Ph.D. (廖倫豪 博士)</a:t>
+              <a:t>AI 時代的智慧財務分析、認知防禦與全維度金融防詐工程論  |  報告人：Howard Liao Ph.D.</a:t>
             </a:r>
           </a:p>
         </p:txBody>
@@ -9141,7 +9141,7 @@
               </a:defRPr>
             </a:pPr>
             <a:r>
-              <a:t>AI 時代的智慧財務分析、認知防禦與全維度金融防詐工程論  |  報告人：Howard Liao Ph.D. (廖倫豪 博士)</a:t>
+              <a:t>AI 時代的智慧財務分析、認知防禦與全維度金融防詐工程論  |  報告人：Howard Liao Ph.D.</a:t>
             </a:r>
           </a:p>
         </p:txBody>
@@ -9274,7 +9274,7 @@
               </a:defRPr>
             </a:pPr>
             <a:r>
-              <a:t>報告人：Howard Liao Ph.D. (廖倫豪 博士)  |  liao.howard@gmail.com</a:t>
+              <a:t>報告人：Howard Liao Ph.D.  |  liao.howard@gmail.com</a:t>
             </a:r>
           </a:p>
         </p:txBody>
@@ -9483,7 +9483,7 @@
               </a:defRPr>
             </a:pPr>
             <a:r>
-              <a:t>AI 時代的智慧財務分析、認知防禦與全維度金融防詐工程論  |  報告人：Howard Liao Ph.D. (廖倫豪 博士)</a:t>
+              <a:t>AI 時代的智慧財務分析、認知防禦與全維度金融防詐工程論  |  報告人：Howard Liao Ph.D.</a:t>
             </a:r>
           </a:p>
         </p:txBody>
@@ -10242,7 +10242,7 @@
               </a:defRPr>
             </a:pPr>
             <a:r>
-              <a:t>AI 時代的智慧財務分析、認知防禦與全維度金融防詐工程論  |  報告人：Howard Liao Ph.D. (廖倫豪 博士)</a:t>
+              <a:t>AI 時代的智慧財務分析、認知防禦與全維度金融防詐工程論  |  報告人：Howard Liao Ph.D.</a:t>
             </a:r>
           </a:p>
         </p:txBody>
@@ -10322,7 +10322,7 @@
               </a:defRPr>
             </a:pPr>
             <a:r>
-              <a:t>Howard Liao Ph.D. (廖倫豪 博士)</a:t>
+              <a:t>Howard Liao Ph.D.</a:t>
             </a:r>
           </a:p>
           <a:p>
@@ -10761,7 +10761,7 @@
               </a:defRPr>
             </a:pPr>
             <a:r>
-              <a:t>AI 時代的智慧財務分析、認知防禦與全維度金融防詐工程論  |  報告人：Howard Liao Ph.D. (廖倫豪 博士)</a:t>
+              <a:t>AI 時代的智慧財務分析、認知防禦與全維度金融防詐工程論  |  報告人：Howard Liao Ph.D.</a:t>
             </a:r>
           </a:p>
         </p:txBody>
@@ -11509,7 +11509,7 @@
               </a:defRPr>
             </a:pPr>
             <a:r>
-              <a:t>AI 時代的智慧財務分析、認知防禦與全維度金融防詐工程論  |  報告人：Howard Liao Ph.D. (廖倫豪 博士)</a:t>
+              <a:t>AI 時代的智慧財務分析、認知防禦與全維度金融防詐工程論  |  報告人：Howard Liao Ph.D.</a:t>
             </a:r>
           </a:p>
         </p:txBody>
@@ -12175,7 +12175,7 @@
               </a:defRPr>
             </a:pPr>
             <a:r>
-              <a:t>AI 時代的智慧財務分析、認知防禦與全維度金融防詐工程論  |  報告人：Howard Liao Ph.D. (廖倫豪 博士)</a:t>
+              <a:t>AI 時代的智慧財務分析、認知防禦與全維度金融防詐工程論  |  報告人：Howard Liao Ph.D.</a:t>
             </a:r>
           </a:p>
         </p:txBody>
@@ -12764,7 +12764,7 @@
               </a:defRPr>
             </a:pPr>
             <a:r>
-              <a:t>AI 時代的智慧財務分析、認知防禦與全維度金融防詐工程論  |  報告人：Howard Liao Ph.D. (廖倫豪 博士)</a:t>
+              <a:t>AI 時代的智慧財務分析、認知防禦與全維度金融防詐工程論  |  報告人：Howard Liao Ph.D.</a:t>
             </a:r>
           </a:p>
         </p:txBody>
@@ -13393,7 +13393,7 @@
               </a:defRPr>
             </a:pPr>
             <a:r>
-              <a:t>AI 時代的智慧財務分析、認知防禦與全維度金融防詐工程論  |  報告人：Howard Liao Ph.D. (廖倫豪 博士)</a:t>
+              <a:t>AI 時代的智慧財務分析、認知防禦與全維度金融防詐工程論  |  報告人：Howard Liao Ph.D.</a:t>
             </a:r>
           </a:p>
         </p:txBody>
@@ -13880,7 +13880,7 @@
               </a:defRPr>
             </a:pPr>
             <a:r>
-              <a:t>AI 時代的智慧財務分析、認知防禦與全維度金融防詐工程論  |  報告人：Howard Liao Ph.D. (廖倫豪 博士)</a:t>
+              <a:t>AI 時代的智慧財務分析、認知防禦與全維度金融防詐工程論  |  報告人：Howard Liao Ph.D.</a:t>
             </a:r>
           </a:p>
         </p:txBody>

</xml_diff>